<commit_message>
test: refresh Inter golden examples
Co-authored-by: Cursor <cursoragent@cursor.com>
</commit_message>
<xml_diff>
--- a/plugins/gradient-cio/assets/examples/gradient-setup.pptx
+++ b/plugins/gradient-cio/assets/examples/gradient-setup.pptx
@@ -3328,7 +3328,7 @@
         <p:spPr>
           <a:xfrm>
             <a:off x="640080" y="1325880"/>
-            <a:ext cx="10908792" cy="1935784"/>
+            <a:ext cx="10908792" cy="1823056"/>
           </a:xfrm>
           <a:prstGeom prst="rect">
             <a:avLst/>
@@ -3373,7 +3373,7 @@
         <p:spPr>
           <a:xfrm>
             <a:off x="640080" y="1325880"/>
-            <a:ext cx="54864" cy="1935784"/>
+            <a:ext cx="54864" cy="1823056"/>
           </a:xfrm>
           <a:prstGeom prst="rect">
             <a:avLst/>
@@ -3457,7 +3457,7 @@
         <p:spPr>
           <a:xfrm>
             <a:off x="804671" y="1719072"/>
-            <a:ext cx="10616184" cy="1451152"/>
+            <a:ext cx="10616184" cy="1338424"/>
           </a:xfrm>
           <a:prstGeom prst="rect">
             <a:avLst/>
@@ -3482,7 +3482,7 @@
               </a:defRPr>
             </a:pPr>
             <a:r>
-              <a:t>GradientCIO is connected and healthy for organization Gradient [S1][S2]. Nine of eleven skills are ready; the macro briefing is ready with one view unavailable, and the IC memo needs the Portfolio and Strategy Lab modules for live portfolio data [S2]. 13 of 14 contract checks passed; the one failure (macro regime state, HTTP 500) is a known issue the skills work around [S3].</a:t>
+              <a:t>GradientCIO is connected and healthy for organization Gradient [S1][S2]. Nineteen of twenty-one skills are ready; the macro briefing has one unavailable view, and the IC memo needs the Portfolio and Strategy Lab modules for live portfolio data [S2]. 13 of 14 contract checks passed; macro regime state returned Not available (HTTP 500) [S3].</a:t>
             </a:r>
           </a:p>
         </p:txBody>
@@ -3495,8 +3495,8 @@
         </p:nvSpPr>
         <p:spPr>
           <a:xfrm>
-            <a:off x="640080" y="3371392"/>
-            <a:ext cx="2644902" cy="1668779"/>
+            <a:off x="640080" y="3258664"/>
+            <a:ext cx="2644902" cy="1737516"/>
           </a:xfrm>
           <a:prstGeom prst="rect">
             <a:avLst/>
@@ -3540,7 +3540,7 @@
         </p:nvSpPr>
         <p:spPr>
           <a:xfrm>
-            <a:off x="640080" y="3371392"/>
+            <a:off x="640080" y="3258664"/>
             <a:ext cx="2644902" cy="45720"/>
           </a:xfrm>
           <a:prstGeom prst="rect">
@@ -3585,7 +3585,7 @@
         </p:nvSpPr>
         <p:spPr>
           <a:xfrm>
-            <a:off x="749808" y="3499408"/>
+            <a:off x="749808" y="3386680"/>
             <a:ext cx="2425446" cy="201168"/>
           </a:xfrm>
           <a:prstGeom prst="rect">
@@ -3624,7 +3624,7 @@
         </p:nvSpPr>
         <p:spPr>
           <a:xfrm>
-            <a:off x="749808" y="3755440"/>
+            <a:off x="749808" y="3642712"/>
             <a:ext cx="2425446" cy="475488"/>
           </a:xfrm>
           <a:prstGeom prst="rect">
@@ -3650,7 +3650,7 @@
               </a:defRPr>
             </a:pPr>
             <a:r>
-              <a:t>9</a:t>
+              <a:t>19</a:t>
             </a:r>
           </a:p>
         </p:txBody>
@@ -3663,7 +3663,7 @@
         </p:nvSpPr>
         <p:spPr>
           <a:xfrm>
-            <a:off x="749808" y="4710988"/>
+            <a:off x="749808" y="4666997"/>
             <a:ext cx="2425446" cy="228600"/>
           </a:xfrm>
           <a:prstGeom prst="rect">
@@ -3689,7 +3689,7 @@
               </a:defRPr>
             </a:pPr>
             <a:r>
-              <a:t>of 11</a:t>
+              <a:t>of 21</a:t>
             </a:r>
           </a:p>
         </p:txBody>
@@ -3702,8 +3702,8 @@
         </p:nvSpPr>
         <p:spPr>
           <a:xfrm>
-            <a:off x="3394710" y="3371392"/>
-            <a:ext cx="2644902" cy="1668779"/>
+            <a:off x="3394710" y="3258664"/>
+            <a:ext cx="2644902" cy="1737516"/>
           </a:xfrm>
           <a:prstGeom prst="rect">
             <a:avLst/>
@@ -3747,7 +3747,7 @@
         </p:nvSpPr>
         <p:spPr>
           <a:xfrm>
-            <a:off x="3394710" y="3371392"/>
+            <a:off x="3394710" y="3258664"/>
             <a:ext cx="2644902" cy="45720"/>
           </a:xfrm>
           <a:prstGeom prst="rect">
@@ -3792,7 +3792,7 @@
         </p:nvSpPr>
         <p:spPr>
           <a:xfrm>
-            <a:off x="3504438" y="3499408"/>
+            <a:off x="3504438" y="3386680"/>
             <a:ext cx="2425446" cy="201168"/>
           </a:xfrm>
           <a:prstGeom prst="rect">
@@ -3831,7 +3831,7 @@
         </p:nvSpPr>
         <p:spPr>
           <a:xfrm>
-            <a:off x="3504438" y="3755440"/>
+            <a:off x="3504438" y="3642712"/>
             <a:ext cx="2425446" cy="475488"/>
           </a:xfrm>
           <a:prstGeom prst="rect">
@@ -3870,7 +3870,7 @@
         </p:nvSpPr>
         <p:spPr>
           <a:xfrm>
-            <a:off x="3504438" y="4710988"/>
+            <a:off x="3504438" y="4666997"/>
             <a:ext cx="2425446" cy="228600"/>
           </a:xfrm>
           <a:prstGeom prst="rect">
@@ -3909,8 +3909,8 @@
         </p:nvSpPr>
         <p:spPr>
           <a:xfrm>
-            <a:off x="6149340" y="3371392"/>
-            <a:ext cx="2644902" cy="1668779"/>
+            <a:off x="6149340" y="3258664"/>
+            <a:ext cx="2644902" cy="1737516"/>
           </a:xfrm>
           <a:prstGeom prst="rect">
             <a:avLst/>
@@ -3954,7 +3954,7 @@
         </p:nvSpPr>
         <p:spPr>
           <a:xfrm>
-            <a:off x="6149340" y="3371392"/>
+            <a:off x="6149340" y="3258664"/>
             <a:ext cx="2644902" cy="45720"/>
           </a:xfrm>
           <a:prstGeom prst="rect">
@@ -3999,7 +3999,7 @@
         </p:nvSpPr>
         <p:spPr>
           <a:xfrm>
-            <a:off x="6259068" y="3499408"/>
+            <a:off x="6259068" y="3386680"/>
             <a:ext cx="2425446" cy="201168"/>
           </a:xfrm>
           <a:prstGeom prst="rect">
@@ -4038,7 +4038,7 @@
         </p:nvSpPr>
         <p:spPr>
           <a:xfrm>
-            <a:off x="6259068" y="3755440"/>
+            <a:off x="6259068" y="3642712"/>
             <a:ext cx="2425446" cy="475488"/>
           </a:xfrm>
           <a:prstGeom prst="rect">
@@ -4077,7 +4077,7 @@
         </p:nvSpPr>
         <p:spPr>
           <a:xfrm>
-            <a:off x="6259068" y="4710988"/>
+            <a:off x="6259068" y="4666997"/>
             <a:ext cx="2425446" cy="228600"/>
           </a:xfrm>
           <a:prstGeom prst="rect">
@@ -4116,8 +4116,8 @@
         </p:nvSpPr>
         <p:spPr>
           <a:xfrm>
-            <a:off x="8903970" y="3371392"/>
-            <a:ext cx="2644902" cy="1668779"/>
+            <a:off x="8903970" y="3258664"/>
+            <a:ext cx="2644902" cy="1737516"/>
           </a:xfrm>
           <a:prstGeom prst="rect">
             <a:avLst/>
@@ -4161,7 +4161,7 @@
         </p:nvSpPr>
         <p:spPr>
           <a:xfrm>
-            <a:off x="8903970" y="3371392"/>
+            <a:off x="8903970" y="3258664"/>
             <a:ext cx="2644902" cy="45720"/>
           </a:xfrm>
           <a:prstGeom prst="rect">
@@ -4206,7 +4206,7 @@
         </p:nvSpPr>
         <p:spPr>
           <a:xfrm>
-            <a:off x="9013698" y="3499408"/>
+            <a:off x="9013698" y="3386680"/>
             <a:ext cx="2425446" cy="201168"/>
           </a:xfrm>
           <a:prstGeom prst="rect">
@@ -4245,7 +4245,7 @@
         </p:nvSpPr>
         <p:spPr>
           <a:xfrm>
-            <a:off x="9013698" y="3755440"/>
+            <a:off x="9013698" y="3642712"/>
             <a:ext cx="2425446" cy="475488"/>
           </a:xfrm>
           <a:prstGeom prst="rect">
@@ -4284,7 +4284,7 @@
         </p:nvSpPr>
         <p:spPr>
           <a:xfrm>
-            <a:off x="9013698" y="4710988"/>
+            <a:off x="9013698" y="4666997"/>
             <a:ext cx="2425446" cy="228600"/>
           </a:xfrm>
           <a:prstGeom prst="rect">
@@ -4310,7 +4310,7 @@
               </a:defRPr>
             </a:pPr>
             <a:r>
-              <a:t>1 known issue</a:t>
+              <a:t>1 unavailable check</a:t>
             </a:r>
           </a:p>
         </p:txBody>
@@ -4323,8 +4323,8 @@
         </p:nvSpPr>
         <p:spPr>
           <a:xfrm>
-            <a:off x="640080" y="5149900"/>
-            <a:ext cx="10908792" cy="1068019"/>
+            <a:off x="640080" y="5105909"/>
+            <a:ext cx="10908792" cy="1112010"/>
           </a:xfrm>
           <a:prstGeom prst="rect">
             <a:avLst/>
@@ -4368,8 +4368,8 @@
         </p:nvSpPr>
         <p:spPr>
           <a:xfrm>
-            <a:off x="640080" y="5149900"/>
-            <a:ext cx="54864" cy="1068019"/>
+            <a:off x="640080" y="5105909"/>
+            <a:ext cx="54864" cy="1112010"/>
           </a:xfrm>
           <a:prstGeom prst="rect">
             <a:avLst/>
@@ -4413,7 +4413,7 @@
         </p:nvSpPr>
         <p:spPr>
           <a:xfrm>
-            <a:off x="804671" y="5259628"/>
+            <a:off x="804671" y="5215637"/>
             <a:ext cx="10616184" cy="228600"/>
           </a:xfrm>
           <a:prstGeom prst="rect">
@@ -4452,8 +4452,8 @@
         </p:nvSpPr>
         <p:spPr>
           <a:xfrm>
-            <a:off x="804671" y="5543092"/>
-            <a:ext cx="10616184" cy="583387"/>
+            <a:off x="804671" y="5499101"/>
+            <a:ext cx="10616184" cy="627378"/>
           </a:xfrm>
           <a:prstGeom prst="rect">
             <a:avLst/>
@@ -9630,7 +9630,7 @@
                         </a:defRPr>
                       </a:pPr>
                       <a:r>
-                        <a:t>● Known issue</a:t>
+                        <a:t>● Not available</a:t>
                       </a:r>
                     </a:p>
                   </a:txBody>
@@ -10422,7 +10422,7 @@
                         </a:defRPr>
                       </a:pPr>
                       <a:r>
-                        <a:t>Risk-free fresh; receipt unvalidated (known)</a:t>
+                        <a:t>Risk-free fresh; receipt validation unavailable</a:t>
                       </a:r>
                     </a:p>
                   </a:txBody>
@@ -10722,7 +10722,7 @@
               </a:defRPr>
             </a:pPr>
             <a:r>
-              <a:t>Every failure matched the known-issues list. Since the last list: the CMA baseline now returns a fresh risk-free rate (previously HTTP 422).</a:t>
+              <a:t>All probes completed without a new failure. The CMA baseline returns a fresh risk-free rate.</a:t>
             </a:r>
           </a:p>
         </p:txBody>

</xml_diff>

<commit_message>
chores: MCP guidance refresh (v2.6.0) (#25)
* chores:1

* fix: use Chromium-compatible Inter font format

Co-authored-by: Cursor <cursoragent@cursor.com>

* fix: prefer installed Inter before bundled fallback

Co-authored-by: Cursor <cursoragent@cursor.com>

* fix: separate bundled and system Inter families

Co-authored-by: Cursor <cursoragent@cursor.com>

* fix: embed static Inter faces for PDF rendering

Co-authored-by: Cursor <cursoragent@cursor.com>

* test: validate static Inter PDF assets

Co-authored-by: Cursor <cursoragent@cursor.com>

* test: refresh Inter golden examples

Co-authored-by: Cursor <cursoragent@cursor.com>

* ci: preserve failed visual examples

Co-authored-by: Cursor <cursoragent@cursor.com>

* test: use Ubuntu golden examples

Co-authored-by: Cursor <cursoragent@cursor.com>

---------

Co-authored-by: shbryx <sbryant@gradientao.com>
Co-authored-by: Cursor <cursoragent@cursor.com>
</commit_message>
<xml_diff>
--- a/plugins/gradient-cio/assets/examples/gradient-setup.pptx
+++ b/plugins/gradient-cio/assets/examples/gradient-setup.pptx
@@ -3328,7 +3328,7 @@
         <p:spPr>
           <a:xfrm>
             <a:off x="640080" y="1325880"/>
-            <a:ext cx="10908792" cy="1935784"/>
+            <a:ext cx="10908792" cy="1823056"/>
           </a:xfrm>
           <a:prstGeom prst="rect">
             <a:avLst/>
@@ -3373,7 +3373,7 @@
         <p:spPr>
           <a:xfrm>
             <a:off x="640080" y="1325880"/>
-            <a:ext cx="54864" cy="1935784"/>
+            <a:ext cx="54864" cy="1823056"/>
           </a:xfrm>
           <a:prstGeom prst="rect">
             <a:avLst/>
@@ -3457,7 +3457,7 @@
         <p:spPr>
           <a:xfrm>
             <a:off x="804671" y="1719072"/>
-            <a:ext cx="10616184" cy="1451152"/>
+            <a:ext cx="10616184" cy="1338424"/>
           </a:xfrm>
           <a:prstGeom prst="rect">
             <a:avLst/>
@@ -3482,7 +3482,7 @@
               </a:defRPr>
             </a:pPr>
             <a:r>
-              <a:t>GradientCIO is connected and healthy for organization Gradient [S1][S2]. Nine of eleven skills are ready; the macro briefing is ready with one view unavailable, and the IC memo needs the Portfolio and Strategy Lab modules for live portfolio data [S2]. 13 of 14 contract checks passed; the one failure (macro regime state, HTTP 500) is a known issue the skills work around [S3].</a:t>
+              <a:t>GradientCIO is connected and healthy for organization Gradient [S1][S2]. Nineteen of twenty-one skills are ready; the macro briefing has one unavailable view, and the IC memo needs the Portfolio and Strategy Lab modules for live portfolio data [S2]. 13 of 14 contract checks passed; macro regime state returned Not available (HTTP 500) [S3].</a:t>
             </a:r>
           </a:p>
         </p:txBody>
@@ -3495,8 +3495,8 @@
         </p:nvSpPr>
         <p:spPr>
           <a:xfrm>
-            <a:off x="640080" y="3371392"/>
-            <a:ext cx="2644902" cy="1668779"/>
+            <a:off x="640080" y="3258664"/>
+            <a:ext cx="2644902" cy="1737516"/>
           </a:xfrm>
           <a:prstGeom prst="rect">
             <a:avLst/>
@@ -3540,7 +3540,7 @@
         </p:nvSpPr>
         <p:spPr>
           <a:xfrm>
-            <a:off x="640080" y="3371392"/>
+            <a:off x="640080" y="3258664"/>
             <a:ext cx="2644902" cy="45720"/>
           </a:xfrm>
           <a:prstGeom prst="rect">
@@ -3585,7 +3585,7 @@
         </p:nvSpPr>
         <p:spPr>
           <a:xfrm>
-            <a:off x="749808" y="3499408"/>
+            <a:off x="749808" y="3386680"/>
             <a:ext cx="2425446" cy="201168"/>
           </a:xfrm>
           <a:prstGeom prst="rect">
@@ -3624,7 +3624,7 @@
         </p:nvSpPr>
         <p:spPr>
           <a:xfrm>
-            <a:off x="749808" y="3755440"/>
+            <a:off x="749808" y="3642712"/>
             <a:ext cx="2425446" cy="475488"/>
           </a:xfrm>
           <a:prstGeom prst="rect">
@@ -3650,7 +3650,7 @@
               </a:defRPr>
             </a:pPr>
             <a:r>
-              <a:t>9</a:t>
+              <a:t>19</a:t>
             </a:r>
           </a:p>
         </p:txBody>
@@ -3663,7 +3663,7 @@
         </p:nvSpPr>
         <p:spPr>
           <a:xfrm>
-            <a:off x="749808" y="4710988"/>
+            <a:off x="749808" y="4666997"/>
             <a:ext cx="2425446" cy="228600"/>
           </a:xfrm>
           <a:prstGeom prst="rect">
@@ -3689,7 +3689,7 @@
               </a:defRPr>
             </a:pPr>
             <a:r>
-              <a:t>of 11</a:t>
+              <a:t>of 21</a:t>
             </a:r>
           </a:p>
         </p:txBody>
@@ -3702,8 +3702,8 @@
         </p:nvSpPr>
         <p:spPr>
           <a:xfrm>
-            <a:off x="3394710" y="3371392"/>
-            <a:ext cx="2644902" cy="1668779"/>
+            <a:off x="3394710" y="3258664"/>
+            <a:ext cx="2644902" cy="1737516"/>
           </a:xfrm>
           <a:prstGeom prst="rect">
             <a:avLst/>
@@ -3747,7 +3747,7 @@
         </p:nvSpPr>
         <p:spPr>
           <a:xfrm>
-            <a:off x="3394710" y="3371392"/>
+            <a:off x="3394710" y="3258664"/>
             <a:ext cx="2644902" cy="45720"/>
           </a:xfrm>
           <a:prstGeom prst="rect">
@@ -3792,7 +3792,7 @@
         </p:nvSpPr>
         <p:spPr>
           <a:xfrm>
-            <a:off x="3504438" y="3499408"/>
+            <a:off x="3504438" y="3386680"/>
             <a:ext cx="2425446" cy="201168"/>
           </a:xfrm>
           <a:prstGeom prst="rect">
@@ -3831,7 +3831,7 @@
         </p:nvSpPr>
         <p:spPr>
           <a:xfrm>
-            <a:off x="3504438" y="3755440"/>
+            <a:off x="3504438" y="3642712"/>
             <a:ext cx="2425446" cy="475488"/>
           </a:xfrm>
           <a:prstGeom prst="rect">
@@ -3870,7 +3870,7 @@
         </p:nvSpPr>
         <p:spPr>
           <a:xfrm>
-            <a:off x="3504438" y="4710988"/>
+            <a:off x="3504438" y="4666997"/>
             <a:ext cx="2425446" cy="228600"/>
           </a:xfrm>
           <a:prstGeom prst="rect">
@@ -3909,8 +3909,8 @@
         </p:nvSpPr>
         <p:spPr>
           <a:xfrm>
-            <a:off x="6149340" y="3371392"/>
-            <a:ext cx="2644902" cy="1668779"/>
+            <a:off x="6149340" y="3258664"/>
+            <a:ext cx="2644902" cy="1737516"/>
           </a:xfrm>
           <a:prstGeom prst="rect">
             <a:avLst/>
@@ -3954,7 +3954,7 @@
         </p:nvSpPr>
         <p:spPr>
           <a:xfrm>
-            <a:off x="6149340" y="3371392"/>
+            <a:off x="6149340" y="3258664"/>
             <a:ext cx="2644902" cy="45720"/>
           </a:xfrm>
           <a:prstGeom prst="rect">
@@ -3999,7 +3999,7 @@
         </p:nvSpPr>
         <p:spPr>
           <a:xfrm>
-            <a:off x="6259068" y="3499408"/>
+            <a:off x="6259068" y="3386680"/>
             <a:ext cx="2425446" cy="201168"/>
           </a:xfrm>
           <a:prstGeom prst="rect">
@@ -4038,7 +4038,7 @@
         </p:nvSpPr>
         <p:spPr>
           <a:xfrm>
-            <a:off x="6259068" y="3755440"/>
+            <a:off x="6259068" y="3642712"/>
             <a:ext cx="2425446" cy="475488"/>
           </a:xfrm>
           <a:prstGeom prst="rect">
@@ -4077,7 +4077,7 @@
         </p:nvSpPr>
         <p:spPr>
           <a:xfrm>
-            <a:off x="6259068" y="4710988"/>
+            <a:off x="6259068" y="4666997"/>
             <a:ext cx="2425446" cy="228600"/>
           </a:xfrm>
           <a:prstGeom prst="rect">
@@ -4116,8 +4116,8 @@
         </p:nvSpPr>
         <p:spPr>
           <a:xfrm>
-            <a:off x="8903970" y="3371392"/>
-            <a:ext cx="2644902" cy="1668779"/>
+            <a:off x="8903970" y="3258664"/>
+            <a:ext cx="2644902" cy="1737516"/>
           </a:xfrm>
           <a:prstGeom prst="rect">
             <a:avLst/>
@@ -4161,7 +4161,7 @@
         </p:nvSpPr>
         <p:spPr>
           <a:xfrm>
-            <a:off x="8903970" y="3371392"/>
+            <a:off x="8903970" y="3258664"/>
             <a:ext cx="2644902" cy="45720"/>
           </a:xfrm>
           <a:prstGeom prst="rect">
@@ -4206,7 +4206,7 @@
         </p:nvSpPr>
         <p:spPr>
           <a:xfrm>
-            <a:off x="9013698" y="3499408"/>
+            <a:off x="9013698" y="3386680"/>
             <a:ext cx="2425446" cy="201168"/>
           </a:xfrm>
           <a:prstGeom prst="rect">
@@ -4245,7 +4245,7 @@
         </p:nvSpPr>
         <p:spPr>
           <a:xfrm>
-            <a:off x="9013698" y="3755440"/>
+            <a:off x="9013698" y="3642712"/>
             <a:ext cx="2425446" cy="475488"/>
           </a:xfrm>
           <a:prstGeom prst="rect">
@@ -4284,7 +4284,7 @@
         </p:nvSpPr>
         <p:spPr>
           <a:xfrm>
-            <a:off x="9013698" y="4710988"/>
+            <a:off x="9013698" y="4666997"/>
             <a:ext cx="2425446" cy="228600"/>
           </a:xfrm>
           <a:prstGeom prst="rect">
@@ -4310,7 +4310,7 @@
               </a:defRPr>
             </a:pPr>
             <a:r>
-              <a:t>1 known issue</a:t>
+              <a:t>1 unavailable check</a:t>
             </a:r>
           </a:p>
         </p:txBody>
@@ -4323,8 +4323,8 @@
         </p:nvSpPr>
         <p:spPr>
           <a:xfrm>
-            <a:off x="640080" y="5149900"/>
-            <a:ext cx="10908792" cy="1068019"/>
+            <a:off x="640080" y="5105909"/>
+            <a:ext cx="10908792" cy="1112010"/>
           </a:xfrm>
           <a:prstGeom prst="rect">
             <a:avLst/>
@@ -4368,8 +4368,8 @@
         </p:nvSpPr>
         <p:spPr>
           <a:xfrm>
-            <a:off x="640080" y="5149900"/>
-            <a:ext cx="54864" cy="1068019"/>
+            <a:off x="640080" y="5105909"/>
+            <a:ext cx="54864" cy="1112010"/>
           </a:xfrm>
           <a:prstGeom prst="rect">
             <a:avLst/>
@@ -4413,7 +4413,7 @@
         </p:nvSpPr>
         <p:spPr>
           <a:xfrm>
-            <a:off x="804671" y="5259628"/>
+            <a:off x="804671" y="5215637"/>
             <a:ext cx="10616184" cy="228600"/>
           </a:xfrm>
           <a:prstGeom prst="rect">
@@ -4452,8 +4452,8 @@
         </p:nvSpPr>
         <p:spPr>
           <a:xfrm>
-            <a:off x="804671" y="5543092"/>
-            <a:ext cx="10616184" cy="583387"/>
+            <a:off x="804671" y="5499101"/>
+            <a:ext cx="10616184" cy="627378"/>
           </a:xfrm>
           <a:prstGeom prst="rect">
             <a:avLst/>
@@ -9630,7 +9630,7 @@
                         </a:defRPr>
                       </a:pPr>
                       <a:r>
-                        <a:t>● Known issue</a:t>
+                        <a:t>● Not available</a:t>
                       </a:r>
                     </a:p>
                   </a:txBody>
@@ -10422,7 +10422,7 @@
                         </a:defRPr>
                       </a:pPr>
                       <a:r>
-                        <a:t>Risk-free fresh; receipt unvalidated (known)</a:t>
+                        <a:t>Risk-free fresh; receipt validation unavailable</a:t>
                       </a:r>
                     </a:p>
                   </a:txBody>
@@ -10722,7 +10722,7 @@
               </a:defRPr>
             </a:pPr>
             <a:r>
-              <a:t>Every failure matched the known-issues list. Since the last list: the CMA baseline now returns a fresh risk-free rate (previously HTTP 422).</a:t>
+              <a:t>All probes completed without a new failure. The CMA baseline returns a fresh risk-free rate.</a:t>
             </a:r>
           </a:p>
         </p:txBody>

</xml_diff>

<commit_message>
feat: release GradientCIO skills v3
Co-authored-by: Cursor <cursoragent@cursor.com>
</commit_message>
<xml_diff>
--- a/plugins/gradient-cio/assets/examples/gradient-setup.pptx
+++ b/plugins/gradient-cio/assets/examples/gradient-setup.pptx
@@ -6023,7 +6023,7 @@
                         <a:rPr>
                           <a:latin typeface="Inter"/>
                         </a:rPr>
-                        <a:t>gradient-ddq-reconcile</a:t>
+                        <a:t>gradient-odd-ddq-reconcile</a:t>
                       </a:r>
                     </a:p>
                   </a:txBody>
@@ -6106,7 +6106,7 @@
                         <a:rPr>
                           <a:latin typeface="Inter"/>
                         </a:rPr>
-                        <a:t>gradient-manager-monitor</a:t>
+                        <a:t>gradient-odd-manager-monitor</a:t>
                       </a:r>
                     </a:p>
                   </a:txBody>
@@ -6556,7 +6556,7 @@
                         <a:rPr>
                           <a:latin typeface="Inter"/>
                         </a:rPr>
-                        <a:t>gradient-macro-brief</a:t>
+                        <a:t>gradient-research-macro-brief</a:t>
                       </a:r>
                     </a:p>
                   </a:txBody>
@@ -6639,7 +6639,7 @@
                         <a:rPr>
                           <a:latin typeface="Inter"/>
                         </a:rPr>
-                        <a:t>gradient-ic-memo</a:t>
+                        <a:t>gradient-decision-ic-memo</a:t>
                       </a:r>
                     </a:p>
                   </a:txBody>

</xml_diff>

<commit_message>
feat: release GradientCIO skills v3 (#34)
Co-authored-by: shbryx <sbryant@gradientao.com>
Co-authored-by: Cursor <cursoragent@cursor.com>
</commit_message>
<xml_diff>
--- a/plugins/gradient-cio/assets/examples/gradient-setup.pptx
+++ b/plugins/gradient-cio/assets/examples/gradient-setup.pptx
@@ -6023,7 +6023,7 @@
                         <a:rPr>
                           <a:latin typeface="Inter"/>
                         </a:rPr>
-                        <a:t>gradient-ddq-reconcile</a:t>
+                        <a:t>gradient-odd-ddq-reconcile</a:t>
                       </a:r>
                     </a:p>
                   </a:txBody>
@@ -6106,7 +6106,7 @@
                         <a:rPr>
                           <a:latin typeface="Inter"/>
                         </a:rPr>
-                        <a:t>gradient-manager-monitor</a:t>
+                        <a:t>gradient-odd-manager-monitor</a:t>
                       </a:r>
                     </a:p>
                   </a:txBody>
@@ -6556,7 +6556,7 @@
                         <a:rPr>
                           <a:latin typeface="Inter"/>
                         </a:rPr>
-                        <a:t>gradient-macro-brief</a:t>
+                        <a:t>gradient-research-macro-brief</a:t>
                       </a:r>
                     </a:p>
                   </a:txBody>
@@ -6639,7 +6639,7 @@
                         <a:rPr>
                           <a:latin typeface="Inter"/>
                         </a:rPr>
-                        <a:t>gradient-ic-memo</a:t>
+                        <a:t>gradient-decision-ic-memo</a:t>
                       </a:r>
                     </a:p>
                   </a:txBody>

</xml_diff>